<commit_message>
feat: update internship at Amazing Tech and add ftacode projects
</commit_message>
<xml_diff>
--- a/doc/logo.pptx
+++ b/doc/logo.pptx
@@ -107,6 +107,11 @@
       </a:defRPr>
     </a:lvl9pPr>
   </p:defaultTextStyle>
+  <p:extLst>
+    <p:ext uri="{EFAFB233-063F-42B5-8137-9DF3F51BA10A}">
+      <p15:sldGuideLst xmlns:p15="http://schemas.microsoft.com/office/powerpoint/2012/main"/>
+    </p:ext>
+  </p:extLst>
 </p:presentation>
 </file>
 
@@ -192,7 +197,7 @@
           <a:p>
             <a:fld id="{4D280842-B767-4237-A8BE-C2432A0C4DDC}" type="datetimeFigureOut">
               <a:rPr lang="en-US" smtClean="0"/>
-              <a:t>8/12/2026</a:t>
+              <a:t>8/22/2026</a:t>
             </a:fld>
             <a:endParaRPr lang="en-US"/>
           </a:p>
@@ -690,7 +695,7 @@
           <a:p>
             <a:fld id="{94B0638B-DE40-494D-A1EB-2AA95C609F7B}" type="datetimeFigureOut">
               <a:rPr lang="en-US" smtClean="0"/>
-              <a:t>8/12/2026</a:t>
+              <a:t>8/22/2026</a:t>
             </a:fld>
             <a:endParaRPr lang="en-US"/>
           </a:p>
@@ -888,7 +893,7 @@
           <a:p>
             <a:fld id="{94B0638B-DE40-494D-A1EB-2AA95C609F7B}" type="datetimeFigureOut">
               <a:rPr lang="en-US" smtClean="0"/>
-              <a:t>8/12/2026</a:t>
+              <a:t>8/22/2026</a:t>
             </a:fld>
             <a:endParaRPr lang="en-US"/>
           </a:p>
@@ -1096,7 +1101,7 @@
           <a:p>
             <a:fld id="{94B0638B-DE40-494D-A1EB-2AA95C609F7B}" type="datetimeFigureOut">
               <a:rPr lang="en-US" smtClean="0"/>
-              <a:t>8/12/2026</a:t>
+              <a:t>8/22/2026</a:t>
             </a:fld>
             <a:endParaRPr lang="en-US"/>
           </a:p>
@@ -1294,7 +1299,7 @@
           <a:p>
             <a:fld id="{94B0638B-DE40-494D-A1EB-2AA95C609F7B}" type="datetimeFigureOut">
               <a:rPr lang="en-US" smtClean="0"/>
-              <a:t>8/12/2026</a:t>
+              <a:t>8/22/2026</a:t>
             </a:fld>
             <a:endParaRPr lang="en-US"/>
           </a:p>
@@ -1569,7 +1574,7 @@
           <a:p>
             <a:fld id="{94B0638B-DE40-494D-A1EB-2AA95C609F7B}" type="datetimeFigureOut">
               <a:rPr lang="en-US" smtClean="0"/>
-              <a:t>8/12/2026</a:t>
+              <a:t>8/22/2026</a:t>
             </a:fld>
             <a:endParaRPr lang="en-US"/>
           </a:p>
@@ -1834,7 +1839,7 @@
           <a:p>
             <a:fld id="{94B0638B-DE40-494D-A1EB-2AA95C609F7B}" type="datetimeFigureOut">
               <a:rPr lang="en-US" smtClean="0"/>
-              <a:t>8/12/2026</a:t>
+              <a:t>8/22/2026</a:t>
             </a:fld>
             <a:endParaRPr lang="en-US"/>
           </a:p>
@@ -2246,7 +2251,7 @@
           <a:p>
             <a:fld id="{94B0638B-DE40-494D-A1EB-2AA95C609F7B}" type="datetimeFigureOut">
               <a:rPr lang="en-US" smtClean="0"/>
-              <a:t>8/12/2026</a:t>
+              <a:t>8/22/2026</a:t>
             </a:fld>
             <a:endParaRPr lang="en-US"/>
           </a:p>
@@ -2387,7 +2392,7 @@
           <a:p>
             <a:fld id="{94B0638B-DE40-494D-A1EB-2AA95C609F7B}" type="datetimeFigureOut">
               <a:rPr lang="en-US" smtClean="0"/>
-              <a:t>8/12/2026</a:t>
+              <a:t>8/22/2026</a:t>
             </a:fld>
             <a:endParaRPr lang="en-US"/>
           </a:p>
@@ -2500,7 +2505,7 @@
           <a:p>
             <a:fld id="{94B0638B-DE40-494D-A1EB-2AA95C609F7B}" type="datetimeFigureOut">
               <a:rPr lang="en-US" smtClean="0"/>
-              <a:t>8/12/2026</a:t>
+              <a:t>8/22/2026</a:t>
             </a:fld>
             <a:endParaRPr lang="en-US"/>
           </a:p>
@@ -2811,7 +2816,7 @@
           <a:p>
             <a:fld id="{94B0638B-DE40-494D-A1EB-2AA95C609F7B}" type="datetimeFigureOut">
               <a:rPr lang="en-US" smtClean="0"/>
-              <a:t>8/12/2026</a:t>
+              <a:t>8/22/2026</a:t>
             </a:fld>
             <a:endParaRPr lang="en-US"/>
           </a:p>
@@ -3099,7 +3104,7 @@
           <a:p>
             <a:fld id="{94B0638B-DE40-494D-A1EB-2AA95C609F7B}" type="datetimeFigureOut">
               <a:rPr lang="en-US" smtClean="0"/>
-              <a:t>8/12/2026</a:t>
+              <a:t>8/22/2026</a:t>
             </a:fld>
             <a:endParaRPr lang="en-US"/>
           </a:p>
@@ -3340,7 +3345,7 @@
           <a:p>
             <a:fld id="{94B0638B-DE40-494D-A1EB-2AA95C609F7B}" type="datetimeFigureOut">
               <a:rPr lang="en-US" smtClean="0"/>
-              <a:t>8/12/2026</a:t>
+              <a:t>8/22/2026</a:t>
             </a:fld>
             <a:endParaRPr lang="en-US"/>
           </a:p>
@@ -4254,7 +4259,7 @@
         </p:nvGrpSpPr>
         <p:grpSpPr>
           <a:xfrm>
-            <a:off x="8353315" y="2929913"/>
+            <a:off x="8346401" y="3124192"/>
             <a:ext cx="1306286" cy="1335602"/>
             <a:chOff x="6894285" y="3717349"/>
             <a:chExt cx="1306286" cy="1335602"/>
@@ -4420,7 +4425,7 @@
         </p:nvGrpSpPr>
         <p:grpSpPr>
           <a:xfrm rot="10800000">
-            <a:off x="7197449" y="2521151"/>
+            <a:off x="7197449" y="2391632"/>
             <a:ext cx="1306286" cy="1335602"/>
             <a:chOff x="6894285" y="3717349"/>
             <a:chExt cx="1306286" cy="1335602"/>
@@ -4752,7 +4757,7 @@
         </p:nvGrpSpPr>
         <p:grpSpPr>
           <a:xfrm>
-            <a:off x="8353315" y="2262112"/>
+            <a:off x="8346401" y="2391632"/>
             <a:ext cx="1306286" cy="1335602"/>
             <a:chOff x="6894285" y="3717349"/>
             <a:chExt cx="1306286" cy="1335602"/>

</xml_diff>